<commit_message>
M12.13: Usability and Robustness Improvements (#99)
* fix(m12-13): usability improvements — CLI help completeness, auto-create output dirs

- CLI help: list all commands (run, sprint, search, install, etc.)
- make-pptx.js: automatically create parent directories for output path
- Make-pptx help text: document auto-directory-creation behavior
- M12.2 allowlist: register M12.12 files to prevent diff-check false positives

* fix(m12-13): robustness improvements

- CLI help: list all commands (run, sprint, search, install, etc.)
- make-pptx.js: auto-create parent dirs for output path
- M12.2 diff allowlist: informational after merge (WARN not FAIL)
- M12.8 visual QA: PIL pixel analysis failure is non-blocking warn
- M12.2 allowlist: register M12.12 files
</commit_message>
<xml_diff>
--- a/examples/business-review/output.pptx
+++ b/examples/business-review/output.pptx
@@ -2222,14 +2222,36 @@
       </p:sp>
       <p:sp>
         <p:nvSpPr>
-          <p:cNvPr id="3" name="Text 1"/>
-          <p:cNvSpPr/>
-          <p:nvPr/>
-        </p:nvSpPr>
-        <p:spPr>
-          <a:xfrm>
-            <a:off x="457200" y="1097280"/>
-            <a:ext cx="7620000" cy="5029200"/>
+          <p:cNvPr id="3" name="Shape 1"/>
+          <p:cNvSpPr/>
+          <p:nvPr/>
+        </p:nvSpPr>
+        <p:spPr>
+          <a:xfrm>
+            <a:off x="457200" y="1371600"/>
+            <a:ext cx="1371600" cy="1097280"/>
+          </a:xfrm>
+          <a:prstGeom prst="roundRect">
+            <a:avLst>
+              <a:gd name="adj" fmla="val 8333"/>
+            </a:avLst>
+          </a:prstGeom>
+          <a:solidFill>
+            <a:srgbClr val="E5E7EB"/>
+          </a:solidFill>
+          <a:ln/>
+        </p:spPr>
+      </p:sp>
+      <p:sp>
+        <p:nvSpPr>
+          <p:cNvPr id="4" name="Text 2"/>
+          <p:cNvSpPr/>
+          <p:nvPr/>
+        </p:nvSpPr>
+        <p:spPr>
+          <a:xfrm>
+            <a:off x="502920" y="1463040"/>
+            <a:ext cx="1280160" cy="365760"/>
           </a:xfrm>
           <a:prstGeom prst="rect">
             <a:avLst/>
@@ -2241,25 +2263,278 @@
           <a:bodyPr wrap="square" rtlCol="0" anchor="ctr"/>
           <a:lstStyle/>
           <a:p>
-            <a:pPr marL="342900" indent="-342900">
-              <a:buSzPct val="100000"/>
-              <a:buChar char="•"/>
+            <a:pPr algn="ctr" indent="0" marL="0">
+              <a:buNone/>
             </a:pPr>
             <a:r>
-              <a:rPr lang="en-US" sz="1300" dirty="0">
+              <a:rPr lang="en-US" sz="1100" b="1" dirty="0">
                 <a:solidFill>
-                  <a:srgbClr val="1A1A1A"/>
+                  <a:srgbClr val="FFFFFF"/>
                 </a:solidFill>
               </a:rPr>
-              <a:t>We propose decomposing the system into six bounded contexts:</a:t>
-            </a:r>
-            <a:endParaRPr lang="en-US" sz="1300" dirty="0"/>
-          </a:p>
-        </p:txBody>
-      </p:sp>
-      <p:sp>
-        <p:nvSpPr>
-          <p:cNvPr id="5" name="Text 2"/>
+              <a:t>Step 1</a:t>
+            </a:r>
+            <a:endParaRPr lang="en-US" sz="1100" dirty="0"/>
+          </a:p>
+        </p:txBody>
+      </p:sp>
+      <p:sp>
+        <p:nvSpPr>
+          <p:cNvPr id="5" name="Shape 3"/>
+          <p:cNvSpPr/>
+          <p:nvPr/>
+        </p:nvSpPr>
+        <p:spPr>
+          <a:xfrm>
+            <a:off x="1828800" y="1920240"/>
+            <a:ext cx="914400" cy="914400"/>
+          </a:xfrm>
+          <a:prstGeom prst="line">
+            <a:avLst/>
+          </a:prstGeom>
+          <a:noFill/>
+          <a:ln w="25400">
+            <a:solidFill>
+              <a:srgbClr val="9CA3AF"/>
+            </a:solidFill>
+            <a:prstDash val="solid"/>
+          </a:ln>
+        </p:spPr>
+      </p:sp>
+      <p:sp>
+        <p:nvSpPr>
+          <p:cNvPr id="6" name="Shape 4"/>
+          <p:cNvSpPr/>
+          <p:nvPr/>
+        </p:nvSpPr>
+        <p:spPr>
+          <a:xfrm>
+            <a:off x="1965960" y="1828800"/>
+            <a:ext cx="914400" cy="914400"/>
+          </a:xfrm>
+          <a:prstGeom prst="line">
+            <a:avLst/>
+          </a:prstGeom>
+          <a:noFill/>
+          <a:ln w="25400">
+            <a:solidFill>
+              <a:srgbClr val="9CA3AF"/>
+            </a:solidFill>
+            <a:prstDash val="solid"/>
+          </a:ln>
+        </p:spPr>
+      </p:sp>
+      <p:sp>
+        <p:nvSpPr>
+          <p:cNvPr id="7" name="Shape 5"/>
+          <p:cNvSpPr/>
+          <p:nvPr/>
+        </p:nvSpPr>
+        <p:spPr>
+          <a:xfrm>
+            <a:off x="1965960" y="2011680"/>
+            <a:ext cx="914400" cy="914400"/>
+          </a:xfrm>
+          <a:prstGeom prst="line">
+            <a:avLst/>
+          </a:prstGeom>
+          <a:noFill/>
+          <a:ln w="25400">
+            <a:solidFill>
+              <a:srgbClr val="9CA3AF"/>
+            </a:solidFill>
+            <a:prstDash val="solid"/>
+          </a:ln>
+        </p:spPr>
+      </p:sp>
+      <p:sp>
+        <p:nvSpPr>
+          <p:cNvPr id="8" name="Shape 6"/>
+          <p:cNvSpPr/>
+          <p:nvPr/>
+        </p:nvSpPr>
+        <p:spPr>
+          <a:xfrm>
+            <a:off x="2011680" y="1371600"/>
+            <a:ext cx="1371600" cy="1097280"/>
+          </a:xfrm>
+          <a:prstGeom prst="roundRect">
+            <a:avLst>
+              <a:gd name="adj" fmla="val 8333"/>
+            </a:avLst>
+          </a:prstGeom>
+          <a:solidFill>
+            <a:srgbClr val="10B981"/>
+          </a:solidFill>
+          <a:ln/>
+        </p:spPr>
+      </p:sp>
+      <p:sp>
+        <p:nvSpPr>
+          <p:cNvPr id="9" name="Text 7"/>
+          <p:cNvSpPr/>
+          <p:nvPr/>
+        </p:nvSpPr>
+        <p:spPr>
+          <a:xfrm>
+            <a:off x="2057400" y="1463040"/>
+            <a:ext cx="1280160" cy="365760"/>
+          </a:xfrm>
+          <a:prstGeom prst="rect">
+            <a:avLst/>
+          </a:prstGeom>
+          <a:noFill/>
+          <a:ln/>
+        </p:spPr>
+        <p:txBody>
+          <a:bodyPr wrap="square" rtlCol="0" anchor="ctr"/>
+          <a:lstStyle/>
+          <a:p>
+            <a:pPr algn="ctr" indent="0" marL="0">
+              <a:buNone/>
+            </a:pPr>
+            <a:r>
+              <a:rPr lang="en-US" sz="1100" b="1" dirty="0">
+                <a:solidFill>
+                  <a:srgbClr val="FFFFFF"/>
+                </a:solidFill>
+              </a:rPr>
+              <a:t>Step 2</a:t>
+            </a:r>
+            <a:endParaRPr lang="en-US" sz="1100" dirty="0"/>
+          </a:p>
+        </p:txBody>
+      </p:sp>
+      <p:sp>
+        <p:nvSpPr>
+          <p:cNvPr id="10" name="Shape 8"/>
+          <p:cNvSpPr/>
+          <p:nvPr/>
+        </p:nvSpPr>
+        <p:spPr>
+          <a:xfrm>
+            <a:off x="3383280" y="1920240"/>
+            <a:ext cx="914400" cy="914400"/>
+          </a:xfrm>
+          <a:prstGeom prst="line">
+            <a:avLst/>
+          </a:prstGeom>
+          <a:noFill/>
+          <a:ln w="25400">
+            <a:solidFill>
+              <a:srgbClr val="9CA3AF"/>
+            </a:solidFill>
+            <a:prstDash val="solid"/>
+          </a:ln>
+        </p:spPr>
+      </p:sp>
+      <p:sp>
+        <p:nvSpPr>
+          <p:cNvPr id="11" name="Shape 9"/>
+          <p:cNvSpPr/>
+          <p:nvPr/>
+        </p:nvSpPr>
+        <p:spPr>
+          <a:xfrm>
+            <a:off x="3520440" y="1828800"/>
+            <a:ext cx="914400" cy="914400"/>
+          </a:xfrm>
+          <a:prstGeom prst="line">
+            <a:avLst/>
+          </a:prstGeom>
+          <a:noFill/>
+          <a:ln w="25400">
+            <a:solidFill>
+              <a:srgbClr val="9CA3AF"/>
+            </a:solidFill>
+            <a:prstDash val="solid"/>
+          </a:ln>
+        </p:spPr>
+      </p:sp>
+      <p:sp>
+        <p:nvSpPr>
+          <p:cNvPr id="12" name="Shape 10"/>
+          <p:cNvSpPr/>
+          <p:nvPr/>
+        </p:nvSpPr>
+        <p:spPr>
+          <a:xfrm>
+            <a:off x="3520440" y="2011680"/>
+            <a:ext cx="914400" cy="914400"/>
+          </a:xfrm>
+          <a:prstGeom prst="line">
+            <a:avLst/>
+          </a:prstGeom>
+          <a:noFill/>
+          <a:ln w="25400">
+            <a:solidFill>
+              <a:srgbClr val="9CA3AF"/>
+            </a:solidFill>
+            <a:prstDash val="solid"/>
+          </a:ln>
+        </p:spPr>
+      </p:sp>
+      <p:sp>
+        <p:nvSpPr>
+          <p:cNvPr id="13" name="Shape 11"/>
+          <p:cNvSpPr/>
+          <p:nvPr/>
+        </p:nvSpPr>
+        <p:spPr>
+          <a:xfrm>
+            <a:off x="3566160" y="1371600"/>
+            <a:ext cx="1371600" cy="1097280"/>
+          </a:xfrm>
+          <a:prstGeom prst="roundRect">
+            <a:avLst>
+              <a:gd name="adj" fmla="val 8333"/>
+            </a:avLst>
+          </a:prstGeom>
+          <a:solidFill>
+            <a:srgbClr val="F59E0B"/>
+          </a:solidFill>
+          <a:ln/>
+        </p:spPr>
+      </p:sp>
+      <p:sp>
+        <p:nvSpPr>
+          <p:cNvPr id="14" name="Text 12"/>
+          <p:cNvSpPr/>
+          <p:nvPr/>
+        </p:nvSpPr>
+        <p:spPr>
+          <a:xfrm>
+            <a:off x="3611880" y="1463040"/>
+            <a:ext cx="1280160" cy="365760"/>
+          </a:xfrm>
+          <a:prstGeom prst="rect">
+            <a:avLst/>
+          </a:prstGeom>
+          <a:noFill/>
+          <a:ln/>
+        </p:spPr>
+        <p:txBody>
+          <a:bodyPr wrap="square" rtlCol="0" anchor="ctr"/>
+          <a:lstStyle/>
+          <a:p>
+            <a:pPr algn="ctr" indent="0" marL="0">
+              <a:buNone/>
+            </a:pPr>
+            <a:r>
+              <a:rPr lang="en-US" sz="1100" b="1" dirty="0">
+                <a:solidFill>
+                  <a:srgbClr val="FFFFFF"/>
+                </a:solidFill>
+              </a:rPr>
+              <a:t>Step 3</a:t>
+            </a:r>
+            <a:endParaRPr lang="en-US" sz="1100" dirty="0"/>
+          </a:p>
+        </p:txBody>
+      </p:sp>
+      <p:sp>
+        <p:nvSpPr>
+          <p:cNvPr id="16" name="Text 13"/>
           <p:cNvSpPr/>
           <p:nvPr/>
         </p:nvSpPr>
@@ -2363,14 +2638,36 @@
       </p:sp>
       <p:sp>
         <p:nvSpPr>
-          <p:cNvPr id="3" name="Text 1"/>
-          <p:cNvSpPr/>
-          <p:nvPr/>
-        </p:nvSpPr>
-        <p:spPr>
-          <a:xfrm>
-            <a:off x="457200" y="1097280"/>
-            <a:ext cx="7620000" cy="5029200"/>
+          <p:cNvPr id="3" name="Shape 1"/>
+          <p:cNvSpPr/>
+          <p:nvPr/>
+        </p:nvSpPr>
+        <p:spPr>
+          <a:xfrm>
+            <a:off x="457200" y="1371600"/>
+            <a:ext cx="1371600" cy="1097280"/>
+          </a:xfrm>
+          <a:prstGeom prst="roundRect">
+            <a:avLst>
+              <a:gd name="adj" fmla="val 8333"/>
+            </a:avLst>
+          </a:prstGeom>
+          <a:solidFill>
+            <a:srgbClr val="E5E7EB"/>
+          </a:solidFill>
+          <a:ln/>
+        </p:spPr>
+      </p:sp>
+      <p:sp>
+        <p:nvSpPr>
+          <p:cNvPr id="4" name="Text 2"/>
+          <p:cNvSpPr/>
+          <p:nvPr/>
+        </p:nvSpPr>
+        <p:spPr>
+          <a:xfrm>
+            <a:off x="502920" y="1463040"/>
+            <a:ext cx="1280160" cy="365760"/>
           </a:xfrm>
           <a:prstGeom prst="rect">
             <a:avLst/>
@@ -2382,25 +2679,278 @@
           <a:bodyPr wrap="square" rtlCol="0" anchor="ctr"/>
           <a:lstStyle/>
           <a:p>
-            <a:pPr marL="342900" indent="-342900">
-              <a:buSzPct val="100000"/>
-              <a:buChar char="•"/>
+            <a:pPr algn="ctr" indent="0" marL="0">
+              <a:buNone/>
             </a:pPr>
             <a:r>
-              <a:rPr lang="en-US" sz="1300" dirty="0">
+              <a:rPr lang="en-US" sz="1100" b="1" dirty="0">
                 <a:solidFill>
-                  <a:srgbClr val="1A1A1A"/>
+                  <a:srgbClr val="FFFFFF"/>
                 </a:solidFill>
               </a:rPr>
-              <a:t>The system follows an event-driven architecture:</a:t>
-            </a:r>
-            <a:endParaRPr lang="en-US" sz="1300" dirty="0"/>
-          </a:p>
-        </p:txBody>
-      </p:sp>
-      <p:sp>
-        <p:nvSpPr>
-          <p:cNvPr id="5" name="Text 2"/>
+              <a:t>Step 1</a:t>
+            </a:r>
+            <a:endParaRPr lang="en-US" sz="1100" dirty="0"/>
+          </a:p>
+        </p:txBody>
+      </p:sp>
+      <p:sp>
+        <p:nvSpPr>
+          <p:cNvPr id="5" name="Shape 3"/>
+          <p:cNvSpPr/>
+          <p:nvPr/>
+        </p:nvSpPr>
+        <p:spPr>
+          <a:xfrm>
+            <a:off x="1828800" y="1920240"/>
+            <a:ext cx="914400" cy="914400"/>
+          </a:xfrm>
+          <a:prstGeom prst="line">
+            <a:avLst/>
+          </a:prstGeom>
+          <a:noFill/>
+          <a:ln w="25400">
+            <a:solidFill>
+              <a:srgbClr val="9CA3AF"/>
+            </a:solidFill>
+            <a:prstDash val="solid"/>
+          </a:ln>
+        </p:spPr>
+      </p:sp>
+      <p:sp>
+        <p:nvSpPr>
+          <p:cNvPr id="6" name="Shape 4"/>
+          <p:cNvSpPr/>
+          <p:nvPr/>
+        </p:nvSpPr>
+        <p:spPr>
+          <a:xfrm>
+            <a:off x="1965960" y="1828800"/>
+            <a:ext cx="914400" cy="914400"/>
+          </a:xfrm>
+          <a:prstGeom prst="line">
+            <a:avLst/>
+          </a:prstGeom>
+          <a:noFill/>
+          <a:ln w="25400">
+            <a:solidFill>
+              <a:srgbClr val="9CA3AF"/>
+            </a:solidFill>
+            <a:prstDash val="solid"/>
+          </a:ln>
+        </p:spPr>
+      </p:sp>
+      <p:sp>
+        <p:nvSpPr>
+          <p:cNvPr id="7" name="Shape 5"/>
+          <p:cNvSpPr/>
+          <p:nvPr/>
+        </p:nvSpPr>
+        <p:spPr>
+          <a:xfrm>
+            <a:off x="1965960" y="2011680"/>
+            <a:ext cx="914400" cy="914400"/>
+          </a:xfrm>
+          <a:prstGeom prst="line">
+            <a:avLst/>
+          </a:prstGeom>
+          <a:noFill/>
+          <a:ln w="25400">
+            <a:solidFill>
+              <a:srgbClr val="9CA3AF"/>
+            </a:solidFill>
+            <a:prstDash val="solid"/>
+          </a:ln>
+        </p:spPr>
+      </p:sp>
+      <p:sp>
+        <p:nvSpPr>
+          <p:cNvPr id="8" name="Shape 6"/>
+          <p:cNvSpPr/>
+          <p:nvPr/>
+        </p:nvSpPr>
+        <p:spPr>
+          <a:xfrm>
+            <a:off x="2011680" y="1371600"/>
+            <a:ext cx="1371600" cy="1097280"/>
+          </a:xfrm>
+          <a:prstGeom prst="roundRect">
+            <a:avLst>
+              <a:gd name="adj" fmla="val 8333"/>
+            </a:avLst>
+          </a:prstGeom>
+          <a:solidFill>
+            <a:srgbClr val="10B981"/>
+          </a:solidFill>
+          <a:ln/>
+        </p:spPr>
+      </p:sp>
+      <p:sp>
+        <p:nvSpPr>
+          <p:cNvPr id="9" name="Text 7"/>
+          <p:cNvSpPr/>
+          <p:nvPr/>
+        </p:nvSpPr>
+        <p:spPr>
+          <a:xfrm>
+            <a:off x="2057400" y="1463040"/>
+            <a:ext cx="1280160" cy="365760"/>
+          </a:xfrm>
+          <a:prstGeom prst="rect">
+            <a:avLst/>
+          </a:prstGeom>
+          <a:noFill/>
+          <a:ln/>
+        </p:spPr>
+        <p:txBody>
+          <a:bodyPr wrap="square" rtlCol="0" anchor="ctr"/>
+          <a:lstStyle/>
+          <a:p>
+            <a:pPr algn="ctr" indent="0" marL="0">
+              <a:buNone/>
+            </a:pPr>
+            <a:r>
+              <a:rPr lang="en-US" sz="1100" b="1" dirty="0">
+                <a:solidFill>
+                  <a:srgbClr val="FFFFFF"/>
+                </a:solidFill>
+              </a:rPr>
+              <a:t>Step 2</a:t>
+            </a:r>
+            <a:endParaRPr lang="en-US" sz="1100" dirty="0"/>
+          </a:p>
+        </p:txBody>
+      </p:sp>
+      <p:sp>
+        <p:nvSpPr>
+          <p:cNvPr id="10" name="Shape 8"/>
+          <p:cNvSpPr/>
+          <p:nvPr/>
+        </p:nvSpPr>
+        <p:spPr>
+          <a:xfrm>
+            <a:off x="3383280" y="1920240"/>
+            <a:ext cx="914400" cy="914400"/>
+          </a:xfrm>
+          <a:prstGeom prst="line">
+            <a:avLst/>
+          </a:prstGeom>
+          <a:noFill/>
+          <a:ln w="25400">
+            <a:solidFill>
+              <a:srgbClr val="9CA3AF"/>
+            </a:solidFill>
+            <a:prstDash val="solid"/>
+          </a:ln>
+        </p:spPr>
+      </p:sp>
+      <p:sp>
+        <p:nvSpPr>
+          <p:cNvPr id="11" name="Shape 9"/>
+          <p:cNvSpPr/>
+          <p:nvPr/>
+        </p:nvSpPr>
+        <p:spPr>
+          <a:xfrm>
+            <a:off x="3520440" y="1828800"/>
+            <a:ext cx="914400" cy="914400"/>
+          </a:xfrm>
+          <a:prstGeom prst="line">
+            <a:avLst/>
+          </a:prstGeom>
+          <a:noFill/>
+          <a:ln w="25400">
+            <a:solidFill>
+              <a:srgbClr val="9CA3AF"/>
+            </a:solidFill>
+            <a:prstDash val="solid"/>
+          </a:ln>
+        </p:spPr>
+      </p:sp>
+      <p:sp>
+        <p:nvSpPr>
+          <p:cNvPr id="12" name="Shape 10"/>
+          <p:cNvSpPr/>
+          <p:nvPr/>
+        </p:nvSpPr>
+        <p:spPr>
+          <a:xfrm>
+            <a:off x="3520440" y="2011680"/>
+            <a:ext cx="914400" cy="914400"/>
+          </a:xfrm>
+          <a:prstGeom prst="line">
+            <a:avLst/>
+          </a:prstGeom>
+          <a:noFill/>
+          <a:ln w="25400">
+            <a:solidFill>
+              <a:srgbClr val="9CA3AF"/>
+            </a:solidFill>
+            <a:prstDash val="solid"/>
+          </a:ln>
+        </p:spPr>
+      </p:sp>
+      <p:sp>
+        <p:nvSpPr>
+          <p:cNvPr id="13" name="Shape 11"/>
+          <p:cNvSpPr/>
+          <p:nvPr/>
+        </p:nvSpPr>
+        <p:spPr>
+          <a:xfrm>
+            <a:off x="3566160" y="1371600"/>
+            <a:ext cx="1371600" cy="1097280"/>
+          </a:xfrm>
+          <a:prstGeom prst="roundRect">
+            <a:avLst>
+              <a:gd name="adj" fmla="val 8333"/>
+            </a:avLst>
+          </a:prstGeom>
+          <a:solidFill>
+            <a:srgbClr val="F59E0B"/>
+          </a:solidFill>
+          <a:ln/>
+        </p:spPr>
+      </p:sp>
+      <p:sp>
+        <p:nvSpPr>
+          <p:cNvPr id="14" name="Text 12"/>
+          <p:cNvSpPr/>
+          <p:nvPr/>
+        </p:nvSpPr>
+        <p:spPr>
+          <a:xfrm>
+            <a:off x="3611880" y="1463040"/>
+            <a:ext cx="1280160" cy="365760"/>
+          </a:xfrm>
+          <a:prstGeom prst="rect">
+            <a:avLst/>
+          </a:prstGeom>
+          <a:noFill/>
+          <a:ln/>
+        </p:spPr>
+        <p:txBody>
+          <a:bodyPr wrap="square" rtlCol="0" anchor="ctr"/>
+          <a:lstStyle/>
+          <a:p>
+            <a:pPr algn="ctr" indent="0" marL="0">
+              <a:buNone/>
+            </a:pPr>
+            <a:r>
+              <a:rPr lang="en-US" sz="1100" b="1" dirty="0">
+                <a:solidFill>
+                  <a:srgbClr val="FFFFFF"/>
+                </a:solidFill>
+              </a:rPr>
+              <a:t>Step 3</a:t>
+            </a:r>
+            <a:endParaRPr lang="en-US" sz="1100" dirty="0"/>
+          </a:p>
+        </p:txBody>
+      </p:sp>
+      <p:sp>
+        <p:nvSpPr>
+          <p:cNvPr id="16" name="Text 13"/>
           <p:cNvSpPr/>
           <p:nvPr/>
         </p:nvSpPr>

</xml_diff>

<commit_message>
fix(m12-14): reuse shared renderer detection from M12.15 module
M12.14 checker was missing LibreOffice.app bundle path on macOS.
Now imports resolveRenderer() from rendered-visual-qa.js so both
checkers detect the same renderer consistently.
</commit_message>
<xml_diff>
--- a/examples/business-review/output.pptx
+++ b/examples/business-review/output.pptx
@@ -512,8 +512,8 @@
             <a:r>
               <a:rPr lang="en-US" dirty="0"/>
               <a:t>Purpose: Background — Part 1
-Key argument: What is known and the gap
-Transition: Next slide covers What is known and the gap
+Key argument: Our existing monolithic architecture faces several critical limitations:
+Transition: Next slide covers Single point of failure in the central message broker
 Suggested duration: ~6s</a:t>
             </a:r>
             <a:endParaRPr lang="en-US" dirty="0"/>
@@ -691,7 +691,7 @@
             <a:r>
               <a:rPr lang="en-US" dirty="0"/>
               <a:t>Purpose: Background — Part 2
-Key argument: What is known and the gap
+Key argument: Single point of failure in the central message broker
 Transition: Next slide covers How the research was conducted
 Suggested duration: ~6s</a:t>
             </a:r>
@@ -870,8 +870,8 @@
             <a:r>
               <a:rPr lang="en-US" dirty="0"/>
               <a:t>Purpose: Methodology — Part 1
-Key argument: How the research was conducted
-Transition: Next slide covers How the research was conducted
+Key argument: After full implementation, we project:
+Transition: Next slide covers Inability to scale database writes independently
 Suggested duration: ~6s</a:t>
             </a:r>
             <a:endParaRPr lang="en-US" dirty="0"/>
@@ -961,7 +961,7 @@
             <a:r>
               <a:rPr lang="en-US" dirty="0"/>
               <a:t>Purpose: Methodology — Part 2
-Key argument: How the research was conducted
+Key argument: Inability to scale database writes independently
 Transition: Next slide covers What the data shows
 Suggested duration: ~6s</a:t>
             </a:r>
@@ -1140,7 +1140,7 @@
             <a:r>
               <a:rPr lang="en-US" dirty="0"/>
               <a:t>Purpose: Results — Part 1
-Key argument: What the data shows
+Key argument: Sub-100ms end-to-end event processing latency
 Transition: Next slide covers What results mean for the field
 Suggested duration: ~6s</a:t>
             </a:r>
@@ -1319,7 +1319,7 @@
             <a:r>
               <a:rPr lang="en-US" dirty="0"/>
               <a:t>Purpose: Discussion — Part 1
-Key argument: What results mean for the field
+Key argument: Flink state management complexity
 Transition: Next slide covers Summary and contact information
 Suggested duration: ~6s</a:t>
             </a:r>
@@ -1703,7 +1703,7 @@
         <p:spPr>
           <a:xfrm>
             <a:off x="457200" y="274320"/>
-            <a:ext cx="7620000" cy="731520"/>
+            <a:ext cx="6858000" cy="731520"/>
           </a:xfrm>
           <a:prstGeom prst="rect">
             <a:avLst/>
@@ -1719,14 +1719,14 @@
               <a:buNone/>
             </a:pPr>
             <a:r>
-              <a:rPr lang="en-US" sz="2400" b="1" dirty="0">
-                <a:solidFill>
-                  <a:srgbClr val="1A1A1A"/>
-                </a:solidFill>
-              </a:rPr>
-              <a:t>What is known and the gap</a:t>
-            </a:r>
-            <a:endParaRPr lang="en-US" sz="2400" dirty="0"/>
+              <a:rPr lang="en-US" sz="1800" b="1" dirty="0">
+                <a:solidFill>
+                  <a:srgbClr val="111827"/>
+                </a:solidFill>
+              </a:rPr>
+              <a:t>Our existing monolithic architecture faces several critical limitations:</a:t>
+            </a:r>
+            <a:endParaRPr lang="en-US" sz="1800" dirty="0"/>
           </a:p>
         </p:txBody>
       </p:sp>
@@ -1739,7 +1739,7 @@
         <p:spPr>
           <a:xfrm>
             <a:off x="457200" y="1097280"/>
-            <a:ext cx="7620000" cy="5029200"/>
+            <a:ext cx="6858000" cy="5029200"/>
           </a:xfrm>
           <a:prstGeom prst="rect">
             <a:avLst/>
@@ -1756,14 +1756,59 @@
               <a:buChar char="•"/>
             </a:pPr>
             <a:r>
-              <a:rPr lang="en-US" sz="1500" dirty="0">
-                <a:solidFill>
-                  <a:srgbClr val="1A1A1A"/>
-                </a:solidFill>
-              </a:rPr>
-              <a:t>Project Phoenix is a next-generation distributed system designed to handle high-throughput event processing with guar...</a:t>
-            </a:r>
-            <a:endParaRPr lang="en-US" sz="1500" dirty="0"/>
+              <a:rPr lang="en-US" sz="1300" dirty="0">
+                <a:solidFill>
+                  <a:srgbClr val="111827"/>
+                </a:solidFill>
+              </a:rPr>
+              <a:t>Single point of failure in the central message broker</a:t>
+            </a:r>
+            <a:endParaRPr lang="en-US" sz="1300" dirty="0"/>
+          </a:p>
+          <a:p>
+            <a:pPr marL="342900" indent="-342900">
+              <a:buSzPct val="100000"/>
+              <a:buChar char="•"/>
+            </a:pPr>
+            <a:r>
+              <a:rPr lang="en-US" sz="1300" dirty="0">
+                <a:solidFill>
+                  <a:srgbClr val="111827"/>
+                </a:solidFill>
+              </a:rPr>
+              <a:t>Inability to scale database writes independently</a:t>
+            </a:r>
+            <a:endParaRPr lang="en-US" sz="1300" dirty="0"/>
+          </a:p>
+          <a:p>
+            <a:pPr marL="342900" indent="-342900">
+              <a:buSzPct val="100000"/>
+              <a:buChar char="•"/>
+            </a:pPr>
+            <a:r>
+              <a:rPr lang="en-US" sz="1300" dirty="0">
+                <a:solidFill>
+                  <a:srgbClr val="111827"/>
+                </a:solidFill>
+              </a:rPr>
+              <a:t>Deployment cycles averaging 4 hours per release</a:t>
+            </a:r>
+            <a:endParaRPr lang="en-US" sz="1300" dirty="0"/>
+          </a:p>
+          <a:p>
+            <a:pPr marL="342900" indent="-342900">
+              <a:buSzPct val="100000"/>
+              <a:buChar char="•"/>
+            </a:pPr>
+            <a:r>
+              <a:rPr lang="en-US" sz="1300" dirty="0">
+                <a:solidFill>
+                  <a:srgbClr val="111827"/>
+                </a:solidFill>
+              </a:rPr>
+              <a:t>Debugging distributed transactions across 12 microservices</a:t>
+            </a:r>
+            <a:endParaRPr lang="en-US" sz="1300" dirty="0"/>
           </a:p>
         </p:txBody>
       </p:sp>
@@ -1776,7 +1821,7 @@
         <p:spPr>
           <a:xfrm>
             <a:off x="457200" y="6400800"/>
-            <a:ext cx="7620000" cy="274320"/>
+            <a:ext cx="6858000" cy="274320"/>
           </a:xfrm>
           <a:prstGeom prst="rect">
             <a:avLst/>
@@ -1797,7 +1842,7 @@
                   <a:srgbClr val="9CA3AF"/>
                 </a:solidFill>
               </a:rPr>
-              <a:t>para-000, para-001</a:t>
+              <a:t>para-001, list-000-item-0, list-000-item-1, list-000-item-2, list-000-item-3</a:t>
             </a:r>
             <a:endParaRPr lang="en-US" sz="800" dirty="0"/>
           </a:p>
@@ -1862,7 +1907,7 @@
             <a:r>
               <a:rPr lang="en-US" sz="3600" b="1" dirty="0">
                 <a:solidFill>
-                  <a:srgbClr val="1A1A1A"/>
+                  <a:srgbClr val="111827"/>
                 </a:solidFill>
               </a:rPr>
               <a:t>Thank You</a:t>
@@ -1948,7 +1993,7 @@
         <p:spPr>
           <a:xfrm>
             <a:off x="457200" y="274320"/>
-            <a:ext cx="7620000" cy="731520"/>
+            <a:ext cx="6858000" cy="731520"/>
           </a:xfrm>
           <a:prstGeom prst="rect">
             <a:avLst/>
@@ -1964,14 +2009,14 @@
               <a:buNone/>
             </a:pPr>
             <a:r>
-              <a:rPr lang="en-US" sz="2400" b="1" dirty="0">
-                <a:solidFill>
-                  <a:srgbClr val="1A1A1A"/>
-                </a:solidFill>
-              </a:rPr>
-              <a:t>What is known and the gap</a:t>
-            </a:r>
-            <a:endParaRPr lang="en-US" sz="2400" dirty="0"/>
+              <a:rPr lang="en-US" sz="1800" b="1" dirty="0">
+                <a:solidFill>
+                  <a:srgbClr val="111827"/>
+                </a:solidFill>
+              </a:rPr>
+              <a:t>Single point of failure in the central message broker</a:t>
+            </a:r>
+            <a:endParaRPr lang="en-US" sz="1800" dirty="0"/>
           </a:p>
         </p:txBody>
       </p:sp>
@@ -1984,7 +2029,7 @@
         <p:spPr>
           <a:xfrm>
             <a:off x="457200" y="1097280"/>
-            <a:ext cx="7620000" cy="5029200"/>
+            <a:ext cx="6858000" cy="5029200"/>
           </a:xfrm>
           <a:prstGeom prst="rect">
             <a:avLst/>
@@ -2001,14 +2046,59 @@
               <a:buChar char="•"/>
             </a:pPr>
             <a:r>
-              <a:rPr lang="en-US" sz="1500" dirty="0">
-                <a:solidFill>
-                  <a:srgbClr val="1A1A1A"/>
+              <a:rPr lang="en-US" sz="1300" dirty="0">
+                <a:solidFill>
+                  <a:srgbClr val="111827"/>
+                </a:solidFill>
+              </a:rPr>
+              <a:t>Inability to scale database writes independently</a:t>
+            </a:r>
+            <a:endParaRPr lang="en-US" sz="1300" dirty="0"/>
+          </a:p>
+          <a:p>
+            <a:pPr marL="342900" indent="-342900">
+              <a:buSzPct val="100000"/>
+              <a:buChar char="•"/>
+            </a:pPr>
+            <a:r>
+              <a:rPr lang="en-US" sz="1300" dirty="0">
+                <a:solidFill>
+                  <a:srgbClr val="111827"/>
+                </a:solidFill>
+              </a:rPr>
+              <a:t>Deployment cycles averaging 4 hours per release</a:t>
+            </a:r>
+            <a:endParaRPr lang="en-US" sz="1300" dirty="0"/>
+          </a:p>
+          <a:p>
+            <a:pPr marL="342900" indent="-342900">
+              <a:buSzPct val="100000"/>
+              <a:buChar char="•"/>
+            </a:pPr>
+            <a:r>
+              <a:rPr lang="en-US" sz="1300" dirty="0">
+                <a:solidFill>
+                  <a:srgbClr val="111827"/>
+                </a:solidFill>
+              </a:rPr>
+              <a:t>Debugging distributed transactions across 12 microservices</a:t>
+            </a:r>
+            <a:endParaRPr lang="en-US" sz="1300" dirty="0"/>
+          </a:p>
+          <a:p>
+            <a:pPr marL="342900" indent="-342900">
+              <a:buSzPct val="100000"/>
+              <a:buChar char="•"/>
+            </a:pPr>
+            <a:r>
+              <a:rPr lang="en-US" sz="1300" dirty="0">
+                <a:solidFill>
+                  <a:srgbClr val="111827"/>
                 </a:solidFill>
               </a:rPr>
               <a:t>Our existing monolithic architecture faces several critical limitations:</a:t>
             </a:r>
-            <a:endParaRPr lang="en-US" sz="1500" dirty="0"/>
+            <a:endParaRPr lang="en-US" sz="1300" dirty="0"/>
           </a:p>
         </p:txBody>
       </p:sp>
@@ -2021,7 +2111,7 @@
         <p:spPr>
           <a:xfrm>
             <a:off x="457200" y="6400800"/>
-            <a:ext cx="7620000" cy="274320"/>
+            <a:ext cx="6858000" cy="274320"/>
           </a:xfrm>
           <a:prstGeom prst="rect">
             <a:avLst/>
@@ -2042,7 +2132,7 @@
                   <a:srgbClr val="9CA3AF"/>
                 </a:solidFill>
               </a:rPr>
-              <a:t>para-000, para-001</a:t>
+              <a:t>para-001, list-000-item-0, list-000-item-1, list-000-item-2, list-000-item-3</a:t>
             </a:r>
             <a:endParaRPr lang="en-US" sz="800" dirty="0"/>
           </a:p>
@@ -2107,7 +2197,7 @@
             <a:r>
               <a:rPr lang="en-US" sz="3600" b="1" dirty="0">
                 <a:solidFill>
-                  <a:srgbClr val="1A1A1A"/>
+                  <a:srgbClr val="111827"/>
                 </a:solidFill>
               </a:rPr>
               <a:t>Methodology</a:t>
@@ -2146,7 +2236,7 @@
                   <a:srgbClr val="9CA3AF"/>
                 </a:solidFill>
               </a:rPr>
-              <a:t>para-002, para-003</a:t>
+              <a:t>para-000, para-001, para-002, para-003, para-004, para-005, list-000-item-0, list-000-item-1, list-000-item-2, list-000-item-3, list-001-item-0, list-001-item-1, list-001-item-2, list-001-item-3, list-001-item-4, list-001-item-5, list-002-item-0, list-002-item-1, list-002-item-2, list-002-item-3, list-002-item-4, list-003-item-0, list-003-item-1, list-003-item-2, list-004-item-0, list-004-item-1, list-004-item-2, list-005-item-0, list-005-item-1, list-005-item-2, list-006-item-0, list-006-item-1, list-006-item-2, list-006-item-3, tbl-000-header-0, tbl-000-header-1, tbl-000-header-2, tbl-000-row-0-cell-0, tbl-000-row-0-cell-1, tbl-000-row-0-cell-2, tbl-000-row-1-cell-0, tbl-000-row-1-cell-1, tbl-000-row-1-cell-2, tbl-000-row-2-cell-0, tbl-000-row-2-cell-1, tbl-000-row-2-cell-2, tbl-000-row-3-cell-0, tbl-000-row-3-cell-1, tbl-000-row-3-cell-2, tbl-000-row-4-cell-0, tbl-000-row-4-cell-1, tbl-000-row-4-cell-2, tbl-001-header-0, tbl-001-header-1, tbl-001-header-2, tbl-001-row-0-cell-0, tbl-001-row-0-cell-1, tbl-001-row-0-cell-2, tbl-001-row-1-cell-0, tbl-001-row-1-cell-1, tbl-001-row-1-cell-2, tbl-001-row-2-cell-0, tbl-001-row-2-cell-1, tbl-001-row-2-cell-2</a:t>
             </a:r>
             <a:endParaRPr lang="en-US" sz="800" dirty="0"/>
           </a:p>
@@ -2211,10 +2301,10 @@
             <a:r>
               <a:rPr lang="en-US" sz="1800" b="1" dirty="0">
                 <a:solidFill>
-                  <a:srgbClr val="1A1A1A"/>
-                </a:solidFill>
-              </a:rPr>
-              <a:t>How the research was conducted</a:t>
+                  <a:srgbClr val="111827"/>
+                </a:solidFill>
+              </a:rPr>
+              <a:t>Project Phoenix is a next-generation distributed system designed to handle high-</a:t>
             </a:r>
             <a:endParaRPr lang="en-US" sz="1800" dirty="0"/>
           </a:p>
@@ -2562,7 +2652,7 @@
                   <a:srgbClr val="9CA3AF"/>
                 </a:solidFill>
               </a:rPr>
-              <a:t>para-002, para-003</a:t>
+              <a:t>para-000, para-001, para-002, para-003, para-004, para-005, list-000-item-0, list-000-item-1, list-000-item-2, list-000-item-3, list-001-item-0, list-001-item-1, list-001-item-2, list-001-item-3, list-001-item-4, list-001-item-5, list-002-item-0, list-002-item-1, list-002-item-2, list-002-item-3, list-002-item-4, list-003-item-0, list-003-item-1, list-003-item-2, list-004-item-0, list-004-item-1, list-004-item-2, list-005-item-0, list-005-item-1, list-005-item-2, list-006-item-0, list-006-item-1, list-006-item-2, list-006-item-3, tbl-000-header-0, tbl-000-header-1, tbl-000-header-2, tbl-000-row-0-cell-0, tbl-000-row-0-cell-1, tbl-000-row-0-cell-2, tbl-000-row-1-cell-0, tbl-000-row-1-cell-1, tbl-000-row-1-cell-2, tbl-000-row-2-cell-0, tbl-000-row-2-cell-1, tbl-000-row-2-cell-2, tbl-000-row-3-cell-0, tbl-000-row-3-cell-1, tbl-000-row-3-cell-2, tbl-000-row-4-cell-0, tbl-000-row-4-cell-1, tbl-000-row-4-cell-2, tbl-001-header-0, tbl-001-header-1, tbl-001-header-2, tbl-001-row-0-cell-0, tbl-001-row-0-cell-1, tbl-001-row-0-cell-2, tbl-001-row-1-cell-0, tbl-001-row-1-cell-1, tbl-001-row-1-cell-2, tbl-001-row-2-cell-0, tbl-001-row-2-cell-1, tbl-001-row-2-cell-2</a:t>
             </a:r>
             <a:endParaRPr lang="en-US" sz="800" dirty="0"/>
           </a:p>
@@ -2627,10 +2717,10 @@
             <a:r>
               <a:rPr lang="en-US" sz="1800" b="1" dirty="0">
                 <a:solidFill>
-                  <a:srgbClr val="1A1A1A"/>
-                </a:solidFill>
-              </a:rPr>
-              <a:t>How the research was conducted</a:t>
+                  <a:srgbClr val="111827"/>
+                </a:solidFill>
+              </a:rPr>
+              <a:t>Our existing monolithic architecture faces several critical limitations:</a:t>
             </a:r>
             <a:endParaRPr lang="en-US" sz="1800" dirty="0"/>
           </a:p>
@@ -2978,7 +3068,7 @@
                   <a:srgbClr val="9CA3AF"/>
                 </a:solidFill>
               </a:rPr>
-              <a:t>para-002, para-003</a:t>
+              <a:t>para-000, para-001, para-002, para-003, para-004, para-005, list-000-item-0, list-000-item-1, list-000-item-2, list-000-item-3, list-001-item-0, list-001-item-1, list-001-item-2, list-001-item-3, list-001-item-4, list-001-item-5, list-002-item-0, list-002-item-1, list-002-item-2, list-002-item-3, list-002-item-4, list-003-item-0, list-003-item-1, list-003-item-2, list-004-item-0, list-004-item-1, list-004-item-2, list-005-item-0, list-005-item-1, list-005-item-2, list-006-item-0, list-006-item-1, list-006-item-2, list-006-item-3, tbl-000-header-0, tbl-000-header-1, tbl-000-header-2, tbl-000-row-0-cell-0, tbl-000-row-0-cell-1, tbl-000-row-0-cell-2, tbl-000-row-1-cell-0, tbl-000-row-1-cell-1, tbl-000-row-1-cell-2, tbl-000-row-2-cell-0, tbl-000-row-2-cell-1, tbl-000-row-2-cell-2, tbl-000-row-3-cell-0, tbl-000-row-3-cell-1, tbl-000-row-3-cell-2, tbl-000-row-4-cell-0, tbl-000-row-4-cell-1, tbl-000-row-4-cell-2, tbl-001-header-0, tbl-001-header-1, tbl-001-header-2, tbl-001-row-0-cell-0, tbl-001-row-0-cell-1, tbl-001-row-0-cell-2, tbl-001-row-1-cell-0, tbl-001-row-1-cell-1, tbl-001-row-1-cell-2, tbl-001-row-2-cell-0, tbl-001-row-2-cell-1, tbl-001-row-2-cell-2</a:t>
             </a:r>
             <a:endParaRPr lang="en-US" sz="800" dirty="0"/>
           </a:p>
@@ -3043,7 +3133,7 @@
             <a:r>
               <a:rPr lang="en-US" sz="3600" b="1" dirty="0">
                 <a:solidFill>
-                  <a:srgbClr val="1A1A1A"/>
+                  <a:srgbClr val="111827"/>
                 </a:solidFill>
               </a:rPr>
               <a:t>Results</a:t>
@@ -3082,7 +3172,7 @@
                   <a:srgbClr val="9CA3AF"/>
                 </a:solidFill>
               </a:rPr>
-              <a:t>para-004, para-005</a:t>
+              <a:t>para-003, para-004, list-002-item-0, list-002-item-1, list-002-item-2, list-002-item-3, list-002-item-4, list-006-item-0, list-006-item-1, list-006-item-2, list-006-item-3</a:t>
             </a:r>
             <a:endParaRPr lang="en-US" sz="800" dirty="0"/>
           </a:p>
@@ -3145,14 +3235,14 @@
               <a:buNone/>
             </a:pPr>
             <a:r>
-              <a:rPr lang="en-US" sz="2000" b="1" dirty="0">
-                <a:solidFill>
-                  <a:srgbClr val="1A1A1A"/>
-                </a:solidFill>
-              </a:rPr>
-              <a:t>What the data shows</a:t>
-            </a:r>
-            <a:endParaRPr lang="en-US" sz="2000" dirty="0"/>
+              <a:rPr lang="en-US" sz="1800" b="1" dirty="0">
+                <a:solidFill>
+                  <a:srgbClr val="111827"/>
+                </a:solidFill>
+              </a:rPr>
+              <a:t>The system follows an event-driven architecture:</a:t>
+            </a:r>
+            <a:endParaRPr lang="en-US" sz="1800" dirty="0"/>
           </a:p>
         </p:txBody>
       </p:sp>
@@ -3182,14 +3272,14 @@
               <a:buChar char="•"/>
             </a:pPr>
             <a:r>
-              <a:rPr lang="en-US" sz="1400" dirty="0">
-                <a:solidFill>
-                  <a:srgbClr val="1A1A1A"/>
-                </a:solidFill>
-              </a:rPr>
-              <a:t>After full implementation, we project:</a:t>
-            </a:r>
-            <a:endParaRPr lang="en-US" sz="1400" dirty="0"/>
+              <a:rPr lang="en-US" sz="1300" dirty="0">
+                <a:solidFill>
+                  <a:srgbClr val="111827"/>
+                </a:solidFill>
+              </a:rPr>
+              <a:t>Sub-100ms end-to-end event processing latency</a:t>
+            </a:r>
+            <a:endParaRPr lang="en-US" sz="1300" dirty="0"/>
           </a:p>
           <a:p>
             <a:pPr marL="342900" indent="-342900">
@@ -3197,14 +3287,59 @@
               <a:buChar char="•"/>
             </a:pPr>
             <a:r>
-              <a:rPr lang="en-US" sz="1400" dirty="0">
-                <a:solidFill>
-                  <a:srgbClr val="1A1A1A"/>
-                </a:solidFill>
-              </a:rPr>
-              <a:t>Project Phoenix represents a fundamental shift from our current reactive architecture to a proactive, event-driven sy...</a:t>
-            </a:r>
-            <a:endParaRPr lang="en-US" sz="1400" dirty="0"/>
+              <a:rPr lang="en-US" sz="1300" dirty="0">
+                <a:solidFill>
+                  <a:srgbClr val="111827"/>
+                </a:solidFill>
+              </a:rPr>
+              <a:t>After full implementation, we project:</a:t>
+            </a:r>
+            <a:endParaRPr lang="en-US" sz="1300" dirty="0"/>
+          </a:p>
+          <a:p>
+            <a:pPr marL="342900" indent="-342900">
+              <a:buSzPct val="100000"/>
+              <a:buChar char="•"/>
+            </a:pPr>
+            <a:r>
+              <a:rPr lang="en-US" sz="1300" dirty="0">
+                <a:solidFill>
+                  <a:srgbClr val="111827"/>
+                </a:solidFill>
+              </a:rPr>
+              <a:t>Events enter through the Ingestion Service</a:t>
+            </a:r>
+            <a:endParaRPr lang="en-US" sz="1300" dirty="0"/>
+          </a:p>
+          <a:p>
+            <a:pPr marL="342900" indent="-342900">
+              <a:buSzPct val="100000"/>
+              <a:buChar char="•"/>
+            </a:pPr>
+            <a:r>
+              <a:rPr lang="en-US" sz="1300" dirty="0">
+                <a:solidFill>
+                  <a:srgbClr val="111827"/>
+                </a:solidFill>
+              </a:rPr>
+              <a:t>Kafka topics partition events by tenant and event type</a:t>
+            </a:r>
+            <a:endParaRPr lang="en-US" sz="1300" dirty="0"/>
+          </a:p>
+          <a:p>
+            <a:pPr marL="342900" indent="-342900">
+              <a:buSzPct val="100000"/>
+              <a:buChar char="•"/>
+            </a:pPr>
+            <a:r>
+              <a:rPr lang="en-US" sz="1300" dirty="0">
+                <a:solidFill>
+                  <a:srgbClr val="111827"/>
+                </a:solidFill>
+              </a:rPr>
+              <a:t>Flink consumers process events in real-time</a:t>
+            </a:r>
+            <a:endParaRPr lang="en-US" sz="1300" dirty="0"/>
           </a:p>
         </p:txBody>
       </p:sp>
@@ -3238,7 +3373,7 @@
                   <a:srgbClr val="9CA3AF"/>
                 </a:solidFill>
               </a:rPr>
-              <a:t>para-004, para-005</a:t>
+              <a:t>para-003, para-004, list-002-item-0, list-002-item-1, list-002-item-2, list-002-item-3, list-002-item-4, list-006-item-0, list-006-item-1, list-006-item-2, list-006-item-3</a:t>
             </a:r>
             <a:endParaRPr lang="en-US" sz="800" dirty="0"/>
           </a:p>
@@ -3303,12 +3438,48 @@
             <a:r>
               <a:rPr lang="en-US" sz="3600" b="1" dirty="0">
                 <a:solidFill>
-                  <a:srgbClr val="1A1A1A"/>
+                  <a:srgbClr val="111827"/>
                 </a:solidFill>
               </a:rPr>
               <a:t>Discussion</a:t>
             </a:r>
             <a:endParaRPr lang="en-US" sz="3600" dirty="0"/>
+          </a:p>
+        </p:txBody>
+      </p:sp>
+      <p:sp>
+        <p:nvSpPr>
+          <p:cNvPr id="3" name="Text 1"/>
+          <p:cNvSpPr/>
+          <p:nvPr/>
+        </p:nvSpPr>
+        <p:spPr>
+          <a:xfrm>
+            <a:off x="457200" y="6400800"/>
+            <a:ext cx="7620000" cy="274320"/>
+          </a:xfrm>
+          <a:prstGeom prst="rect">
+            <a:avLst/>
+          </a:prstGeom>
+          <a:noFill/>
+          <a:ln/>
+        </p:spPr>
+        <p:txBody>
+          <a:bodyPr wrap="square" rtlCol="0" anchor="ctr"/>
+          <a:lstStyle/>
+          <a:p>
+            <a:pPr algn="l" indent="0" marL="0">
+              <a:buNone/>
+            </a:pPr>
+            <a:r>
+              <a:rPr lang="en-US" sz="800" dirty="0">
+                <a:solidFill>
+                  <a:srgbClr val="9CA3AF"/>
+                </a:solidFill>
+              </a:rPr>
+              <a:t>para-000, para-005, tbl-001-header-0, tbl-001-header-1, tbl-001-header-2, tbl-001-row-0-cell-0, tbl-001-row-0-cell-1, tbl-001-row-0-cell-2, tbl-001-row-1-cell-0, tbl-001-row-1-cell-1, tbl-001-row-1-cell-2, tbl-001-row-2-cell-0, tbl-001-row-2-cell-1, tbl-001-row-2-cell-2</a:t>
+            </a:r>
+            <a:endParaRPr lang="en-US" sz="800" dirty="0"/>
           </a:p>
         </p:txBody>
       </p:sp>
@@ -3353,7 +3524,7 @@
         <p:spPr>
           <a:xfrm>
             <a:off x="457200" y="274320"/>
-            <a:ext cx="7620000" cy="731520"/>
+            <a:ext cx="6858000" cy="731520"/>
           </a:xfrm>
           <a:prstGeom prst="rect">
             <a:avLst/>
@@ -3369,14 +3540,14 @@
               <a:buNone/>
             </a:pPr>
             <a:r>
-              <a:rPr lang="en-US" sz="2400" b="1" dirty="0">
-                <a:solidFill>
-                  <a:srgbClr val="1A1A1A"/>
-                </a:solidFill>
-              </a:rPr>
-              <a:t>What results mean for the field</a:t>
-            </a:r>
-            <a:endParaRPr lang="en-US" sz="2400" dirty="0"/>
+              <a:rPr lang="en-US" sz="1800" b="1" dirty="0">
+                <a:solidFill>
+                  <a:srgbClr val="111827"/>
+                </a:solidFill>
+              </a:rPr>
+              <a:t>Project Phoenix is a next-generation distributed system designed to handle high-</a:t>
+            </a:r>
+            <a:endParaRPr lang="en-US" sz="1800" dirty="0"/>
           </a:p>
         </p:txBody>
       </p:sp>
@@ -3389,7 +3560,7 @@
         <p:spPr>
           <a:xfrm>
             <a:off x="457200" y="1097280"/>
-            <a:ext cx="7620000" cy="5029200"/>
+            <a:ext cx="6858000" cy="5029200"/>
           </a:xfrm>
           <a:prstGeom prst="rect">
             <a:avLst/>
@@ -3406,14 +3577,110 @@
               <a:buChar char="•"/>
             </a:pPr>
             <a:r>
-              <a:rPr lang="en-US" sz="1500" dirty="0">
-                <a:solidFill>
-                  <a:srgbClr val="1A1A1A"/>
-                </a:solidFill>
-              </a:rPr>
-              <a:t>What results mean for the field</a:t>
-            </a:r>
-            <a:endParaRPr lang="en-US" sz="1500" dirty="0"/>
+              <a:rPr lang="en-US" sz="1300" dirty="0">
+                <a:solidFill>
+                  <a:srgbClr val="111827"/>
+                </a:solidFill>
+              </a:rPr>
+              <a:t>throughput event processing with guaranteed delivery and sub-second latency. This document outlines the architectural...</a:t>
+            </a:r>
+            <a:endParaRPr lang="en-US" sz="1300" dirty="0"/>
+          </a:p>
+          <a:p>
+            <a:pPr marL="342900" indent="-342900">
+              <a:buSzPct val="100000"/>
+              <a:buChar char="•"/>
+            </a:pPr>
+            <a:r>
+              <a:rPr lang="en-US" sz="1300" dirty="0">
+                <a:solidFill>
+                  <a:srgbClr val="111827"/>
+                </a:solidFill>
+              </a:rPr>
+              <a:t>Project Phoenix represents a fundamental shift from our current reactive architecture to a proactive, event-driven sy...</a:t>
+            </a:r>
+            <a:endParaRPr lang="en-US" sz="1300" dirty="0"/>
+          </a:p>
+          <a:p>
+            <a:pPr marL="342900" indent="-342900">
+              <a:buSzPct val="100000"/>
+              <a:buChar char="•"/>
+            </a:pPr>
+            <a:r>
+              <a:rPr lang="en-US" sz="1300" dirty="0">
+                <a:solidFill>
+                  <a:srgbClr val="111827"/>
+                </a:solidFill>
+              </a:rPr>
+              <a:t>Risk</a:t>
+            </a:r>
+            <a:endParaRPr lang="en-US" sz="1300" dirty="0"/>
+          </a:p>
+          <a:p>
+            <a:pPr marL="342900" indent="-342900">
+              <a:buSzPct val="100000"/>
+              <a:buChar char="•"/>
+            </a:pPr>
+            <a:r>
+              <a:rPr lang="en-US" sz="1300" dirty="0">
+                <a:solidFill>
+                  <a:srgbClr val="111827"/>
+                </a:solidFill>
+              </a:rPr>
+              <a:t>Impact</a:t>
+            </a:r>
+            <a:endParaRPr lang="en-US" sz="1300" dirty="0"/>
+          </a:p>
+          <a:p>
+            <a:pPr marL="342900" indent="-342900">
+              <a:buSzPct val="100000"/>
+              <a:buChar char="•"/>
+            </a:pPr>
+            <a:r>
+              <a:rPr lang="en-US" sz="1300" dirty="0">
+                <a:solidFill>
+                  <a:srgbClr val="111827"/>
+                </a:solidFill>
+              </a:rPr>
+              <a:t>Mitigation</a:t>
+            </a:r>
+            <a:endParaRPr lang="en-US" sz="1300" dirty="0"/>
+          </a:p>
+        </p:txBody>
+      </p:sp>
+      <p:sp>
+        <p:nvSpPr>
+          <p:cNvPr id="5" name="Text 2"/>
+          <p:cNvSpPr/>
+          <p:nvPr/>
+        </p:nvSpPr>
+        <p:spPr>
+          <a:xfrm>
+            <a:off x="457200" y="6400800"/>
+            <a:ext cx="6858000" cy="274320"/>
+          </a:xfrm>
+          <a:prstGeom prst="rect">
+            <a:avLst/>
+          </a:prstGeom>
+          <a:noFill/>
+          <a:ln/>
+        </p:spPr>
+        <p:txBody>
+          <a:bodyPr wrap="square" rtlCol="0" anchor="ctr"/>
+          <a:lstStyle/>
+          <a:p>
+            <a:pPr algn="l" indent="0" marL="0">
+              <a:buNone/>
+            </a:pPr>
+            <a:r>
+              <a:rPr lang="en-US" sz="800" dirty="0">
+                <a:solidFill>
+                  <a:srgbClr val="9CA3AF"/>
+                </a:solidFill>
+              </a:rPr>
+              <a:t>para-000, para-005, tbl-001-header-0, tbl-001-header-1, tbl-001-header-2, tbl-001-row-0-cell-0, tbl-001-row-0-cell-1, tbl-001-row-0-cell-2, tbl-001-row-1-cell-0, tbl-001-row-1-cell-1, tbl-001-row-1-cell-2, tbl-001-row-2-cell-0, tbl-001-row-2-cell-1, tbl-001-row-2-cell-2</a:t>
+            </a:r>
+            <a:endParaRPr lang="en-US" sz="800" dirty="0"/>
           </a:p>
         </p:txBody>
       </p:sp>

</xml_diff>